<commit_message>
Opcion C: sin fork. Los participantes clonan el repo publico; A.4 es commit local y A.5 pasa a demostracion del presentador
</commit_message>
<xml_diff>
--- a/guia-presentador/Workshop-Deck-Etapas.pptx
+++ b/guia-presentador/Workshop-Deck-Etapas.pptx
@@ -4713,7 +4713,7 @@
                 <a:ea typeface="Segoe UI" pitchFamily="34" charset="-122"/>
                 <a:cs typeface="Segoe UI" pitchFamily="34" charset="-120"/>
               </a:rPr>
-              <a:t>github.com/tinocodemos/ghcp-workshop-calidad</a:t>
+              <a:t>github.com/tinocoh/ghcp-workshop-calidad</a:t>
             </a:r>
             <a:endParaRPr lang="en-US" sz="1150" dirty="0"/>
           </a:p>
@@ -7722,7 +7722,7 @@
                 <a:ea typeface="Segoe UI" pitchFamily="34" charset="-122"/>
                 <a:cs typeface="Segoe UI" pitchFamily="34" charset="-120"/>
               </a:rPr>
-              <a:t>Ejercicio A.4</a:t>
+              <a:t>Demostración</a:t>
             </a:r>
             <a:endParaRPr lang="en-US" sz="1000" dirty="0"/>
           </a:p>
@@ -7834,7 +7834,7 @@
                 <a:ea typeface="Segoe UI" pitchFamily="34" charset="-122"/>
                 <a:cs typeface="Segoe UI" pitchFamily="34" charset="-120"/>
               </a:rPr>
-              <a:t>El flujo real de tu organización</a:t>
+              <a:t>El mismo flujo, ahora en GitHub</a:t>
             </a:r>
             <a:endParaRPr lang="en-US" sz="1050" dirty="0"/>
           </a:p>
@@ -7880,7 +7880,7 @@
                 <a:ea typeface="Segoe UI" pitchFamily="34" charset="-122"/>
                 <a:cs typeface="Segoe UI" pitchFamily="34" charset="-120"/>
               </a:rPr>
-              <a:t>Commit suggestion y Fix with Copilot</a:t>
+              <a:t>Lo proyecta el presentador</a:t>
             </a:r>
             <a:endParaRPr lang="en-US" sz="1050" dirty="0"/>
           </a:p>

</xml_diff>